<commit_message>
Generate class assets from source content and expose downloads
</commit_message>
<xml_diff>
--- a/docs/presentaciones/classes/clase-00-diagnostico-inicial-presentacion.pptx
+++ b/docs/presentaciones/classes/clase-00-diagnostico-inicial-presentacion.pptx
@@ -12,6 +12,7 @@
     <p:sldId id="260" r:id="rId11"/>
     <p:sldId id="261" r:id="rId12"/>
     <p:sldId id="262" r:id="rId13"/>
+    <p:sldId id="263" r:id="rId14"/>
   </p:sldIdLst>
   <p:sldSz cx="12191695" cy="6858000" type="screen4x3"/>
   <p:notesSz cx="6858000" cy="9144000"/>
@@ -3215,7 +3216,7 @@
           <a:lstStyle/>
           <a:p>
             <a:pPr>
-              <a:defRPr sz="2400">
+              <a:defRPr sz="2300">
                 <a:solidFill>
                   <a:srgbClr val="F1F5F9"/>
                 </a:solidFill>
@@ -3223,7 +3224,7 @@
               </a:defRPr>
             </a:pPr>
             <a:r>
-              <a:t>🧭 Clase 00: Diagnóstico inicial y orientación</a:t>
+              <a:t>Clase 00: Diagnóstico inicial y orientación</a:t>
             </a:r>
           </a:p>
         </p:txBody>
@@ -3236,8 +3237,8 @@
         </p:nvSpPr>
         <p:spPr>
           <a:xfrm>
-            <a:off x="658368" y="1325880"/>
-            <a:ext cx="10881360" cy="457200"/>
+            <a:off x="658368" y="1298448"/>
+            <a:ext cx="10881360" cy="502920"/>
           </a:xfrm>
           <a:prstGeom prst="rect">
             <a:avLst/>
@@ -3259,7 +3260,7 @@
               </a:defRPr>
             </a:pPr>
             <a:r>
-              <a:t>15 minutos | Nivel Diagnóstico | Dataset: No requiere dataset.</a:t>
+              <a:t>No requiere dataset.</a:t>
             </a:r>
           </a:p>
         </p:txBody>
@@ -3272,7 +3273,7 @@
         </p:nvSpPr>
         <p:spPr>
           <a:xfrm>
-            <a:off x="731520" y="1965960"/>
+            <a:off x="731520" y="1938528"/>
             <a:ext cx="10698480" cy="2926080"/>
           </a:xfrm>
           <a:prstGeom prst="rect">
@@ -3290,7 +3291,7 @@
               <a:spcAft>
                 <a:spcPts val="1800"/>
               </a:spcAft>
-              <a:defRPr sz="2800">
+              <a:defRPr sz="2700">
                 <a:solidFill>
                   <a:srgbClr val="F1F5F9"/>
                 </a:solidFill>
@@ -3455,7 +3456,7 @@
           <a:lstStyle/>
           <a:p>
             <a:pPr>
-              <a:defRPr sz="2400">
+              <a:defRPr sz="2300">
                 <a:solidFill>
                   <a:srgbClr val="F1F5F9"/>
                 </a:solidFill>
@@ -3463,21 +3464,57 @@
               </a:defRPr>
             </a:pPr>
             <a:r>
-              <a:t>🎯 Logros y focos del módulo</a:t>
-            </a:r>
-          </a:p>
-        </p:txBody>
-      </p:sp>
-      <p:sp>
-        <p:nvSpPr>
-          <p:cNvPr id="5" name="Rounded Rectangle 4"/>
+              <a:t>🎯 Foco del módulo</a:t>
+            </a:r>
+          </a:p>
+        </p:txBody>
+      </p:sp>
+      <p:sp>
+        <p:nvSpPr>
+          <p:cNvPr id="5" name="TextBox 4"/>
+          <p:cNvSpPr txBox="1"/>
+          <p:nvPr/>
+        </p:nvSpPr>
+        <p:spPr>
+          <a:xfrm>
+            <a:off x="658368" y="1298448"/>
+            <a:ext cx="10881360" cy="502920"/>
+          </a:xfrm>
+          <a:prstGeom prst="rect">
+            <a:avLst/>
+          </a:prstGeom>
+          <a:noFill/>
+        </p:spPr>
+        <p:txBody>
+          <a:bodyPr wrap="square">
+            <a:spAutoFit/>
+          </a:bodyPr>
+          <a:lstStyle/>
+          <a:p>
+            <a:pPr>
+              <a:defRPr sz="1100">
+                <a:solidFill>
+                  <a:srgbClr val="94A3B8"/>
+                </a:solidFill>
+                <a:latin typeface="Segoe UI"/>
+              </a:defRPr>
+            </a:pPr>
+            <a:r>
+              <a:t>Resumen tomado desde README.md.</a:t>
+            </a:r>
+          </a:p>
+        </p:txBody>
+      </p:sp>
+      <p:sp>
+        <p:nvSpPr>
+          <p:cNvPr id="6" name="Rounded Rectangle 5"/>
           <p:cNvSpPr/>
           <p:nvPr/>
         </p:nvSpPr>
         <p:spPr>
           <a:xfrm>
             <a:off x="731520" y="1783080"/>
-            <a:ext cx="4663440" cy="4023360"/>
+            <a:ext cx="4663440" cy="4114800"/>
           </a:xfrm>
           <a:prstGeom prst="roundRect">
             <a:avLst/>
@@ -3515,7 +3552,7 @@
       </p:sp>
       <p:sp>
         <p:nvSpPr>
-          <p:cNvPr id="6" name="TextBox 5"/>
+          <p:cNvPr id="7" name="TextBox 6"/>
           <p:cNvSpPr txBox="1"/>
           <p:nvPr/>
         </p:nvSpPr>
@@ -3544,21 +3581,21 @@
               </a:defRPr>
             </a:pPr>
             <a:r>
-              <a:t>Temas clave</a:t>
-            </a:r>
-          </a:p>
-        </p:txBody>
-      </p:sp>
-      <p:sp>
-        <p:nvSpPr>
-          <p:cNvPr id="7" name="TextBox 6"/>
+              <a:t>Resultados esperados</a:t>
+            </a:r>
+          </a:p>
+        </p:txBody>
+      </p:sp>
+      <p:sp>
+        <p:nvSpPr>
+          <p:cNvPr id="8" name="TextBox 7"/>
           <p:cNvSpPr txBox="1"/>
           <p:nvPr/>
         </p:nvSpPr>
         <p:spPr>
           <a:xfrm>
             <a:off x="914400" y="2377440"/>
-            <a:ext cx="4297680" cy="3108960"/>
+            <a:ext cx="4297680" cy="3200400"/>
           </a:xfrm>
           <a:prstGeom prst="rect">
             <a:avLst/>
@@ -3583,7 +3620,7 @@
               </a:defRPr>
             </a:pPr>
             <a:r>
-              <a:t>Python básico</a:t>
+              <a:t>Identificar fortalezas iniciales.</a:t>
             </a:r>
           </a:p>
           <a:p>
@@ -3599,7 +3636,7 @@
               </a:defRPr>
             </a:pPr>
             <a:r>
-              <a:t>Lectura de tablas</a:t>
+              <a:t>Detectar vacíos de apoyo.</a:t>
             </a:r>
           </a:p>
           <a:p>
@@ -3615,53 +3652,21 @@
               </a:defRPr>
             </a:pPr>
             <a:r>
-              <a:t>Gráficos</a:t>
-            </a:r>
-          </a:p>
-          <a:p>
-            <a:pPr>
-              <a:spcAft>
-                <a:spcPts val="800"/>
-              </a:spcAft>
-              <a:defRPr sz="1700">
-                <a:solidFill>
-                  <a:srgbClr val="F1F5F9"/>
-                </a:solidFill>
-                <a:latin typeface="Segoe UI"/>
-              </a:defRPr>
-            </a:pPr>
-            <a:r>
-              <a:t>Modelado inicial</a:t>
-            </a:r>
-          </a:p>
-          <a:p>
-            <a:pPr>
-              <a:spcAft>
-                <a:spcPts val="800"/>
-              </a:spcAft>
-              <a:defRPr sz="1700">
-                <a:solidFill>
-                  <a:srgbClr val="F1F5F9"/>
-                </a:solidFill>
-                <a:latin typeface="Segoe UI"/>
-              </a:defRPr>
-            </a:pPr>
-            <a:r>
-              <a:t>Hábitos de trabajo</a:t>
-            </a:r>
-          </a:p>
-        </p:txBody>
-      </p:sp>
-      <p:sp>
-        <p:nvSpPr>
-          <p:cNvPr id="8" name="Rounded Rectangle 7"/>
+              <a:t>Alinear expectativas del recorrido.</a:t>
+            </a:r>
+          </a:p>
+        </p:txBody>
+      </p:sp>
+      <p:sp>
+        <p:nvSpPr>
+          <p:cNvPr id="9" name="Rounded Rectangle 8"/>
           <p:cNvSpPr/>
           <p:nvPr/>
         </p:nvSpPr>
         <p:spPr>
           <a:xfrm>
             <a:off x="6217920" y="1783080"/>
-            <a:ext cx="4663440" cy="4023360"/>
+            <a:ext cx="4663440" cy="4114800"/>
           </a:xfrm>
           <a:prstGeom prst="roundRect">
             <a:avLst/>
@@ -3699,7 +3704,7 @@
       </p:sp>
       <p:sp>
         <p:nvSpPr>
-          <p:cNvPr id="9" name="TextBox 8"/>
+          <p:cNvPr id="10" name="TextBox 9"/>
           <p:cNvSpPr txBox="1"/>
           <p:nvPr/>
         </p:nvSpPr>
@@ -3728,21 +3733,21 @@
               </a:defRPr>
             </a:pPr>
             <a:r>
-              <a:t>Resultados esperados</a:t>
-            </a:r>
-          </a:p>
-        </p:txBody>
-      </p:sp>
-      <p:sp>
-        <p:nvSpPr>
-          <p:cNvPr id="10" name="TextBox 9"/>
+              <a:t>Temas clave</a:t>
+            </a:r>
+          </a:p>
+        </p:txBody>
+      </p:sp>
+      <p:sp>
+        <p:nvSpPr>
+          <p:cNvPr id="11" name="TextBox 10"/>
           <p:cNvSpPr txBox="1"/>
           <p:nvPr/>
         </p:nvSpPr>
         <p:spPr>
           <a:xfrm>
             <a:off x="6400800" y="2377440"/>
-            <a:ext cx="4297680" cy="3108960"/>
+            <a:ext cx="4297680" cy="3200400"/>
           </a:xfrm>
           <a:prstGeom prst="rect">
             <a:avLst/>
@@ -3767,7 +3772,7 @@
               </a:defRPr>
             </a:pPr>
             <a:r>
-              <a:t>Identificar fortalezas iniciales.</a:t>
+              <a:t>Python básico</a:t>
             </a:r>
           </a:p>
           <a:p>
@@ -3783,7 +3788,7 @@
               </a:defRPr>
             </a:pPr>
             <a:r>
-              <a:t>Detectar vacíos de apoyo.</a:t>
+              <a:t>Lectura de tablas</a:t>
             </a:r>
           </a:p>
           <a:p>
@@ -3799,7 +3804,39 @@
               </a:defRPr>
             </a:pPr>
             <a:r>
-              <a:t>Alinear expectativas del recorrido.</a:t>
+              <a:t>Gráficos</a:t>
+            </a:r>
+          </a:p>
+          <a:p>
+            <a:pPr>
+              <a:spcAft>
+                <a:spcPts val="800"/>
+              </a:spcAft>
+              <a:defRPr sz="1700">
+                <a:solidFill>
+                  <a:srgbClr val="F1F5F9"/>
+                </a:solidFill>
+                <a:latin typeface="Segoe UI"/>
+              </a:defRPr>
+            </a:pPr>
+            <a:r>
+              <a:t>Modelado inicial</a:t>
+            </a:r>
+          </a:p>
+          <a:p>
+            <a:pPr>
+              <a:spcAft>
+                <a:spcPts val="800"/>
+              </a:spcAft>
+              <a:defRPr sz="1700">
+                <a:solidFill>
+                  <a:srgbClr val="F1F5F9"/>
+                </a:solidFill>
+                <a:latin typeface="Segoe UI"/>
+              </a:defRPr>
+            </a:pPr>
+            <a:r>
+              <a:t>Hábitos de trabajo</a:t>
             </a:r>
           </a:p>
         </p:txBody>
@@ -3943,7 +3980,7 @@
           <a:lstStyle/>
           <a:p>
             <a:pPr>
-              <a:defRPr sz="2400">
+              <a:defRPr sz="2300">
                 <a:solidFill>
                   <a:srgbClr val="F1F5F9"/>
                 </a:solidFill>
@@ -3951,7 +3988,7 @@
               </a:defRPr>
             </a:pPr>
             <a:r>
-              <a:t>🧭 Ruta sugerida de la sesión</a:t>
+              <a:t>🖥️ Ruta sugerida de la sesión</a:t>
             </a:r>
           </a:p>
         </p:txBody>
@@ -3959,6 +3996,42 @@
       <p:sp>
         <p:nvSpPr>
           <p:cNvPr id="5" name="TextBox 4"/>
+          <p:cNvSpPr txBox="1"/>
+          <p:nvPr/>
+        </p:nvSpPr>
+        <p:spPr>
+          <a:xfrm>
+            <a:off x="658368" y="1298448"/>
+            <a:ext cx="10881360" cy="502920"/>
+          </a:xfrm>
+          <a:prstGeom prst="rect">
+            <a:avLst/>
+          </a:prstGeom>
+          <a:noFill/>
+        </p:spPr>
+        <p:txBody>
+          <a:bodyPr wrap="square">
+            <a:spAutoFit/>
+          </a:bodyPr>
+          <a:lstStyle/>
+          <a:p>
+            <a:pPr>
+              <a:defRPr sz="1100">
+                <a:solidFill>
+                  <a:srgbClr val="94A3B8"/>
+                </a:solidFill>
+                <a:latin typeface="Segoe UI"/>
+              </a:defRPr>
+            </a:pPr>
+            <a:r>
+              <a:t>Resumen tomado desde slides.md.</a:t>
+            </a:r>
+          </a:p>
+        </p:txBody>
+      </p:sp>
+      <p:sp>
+        <p:nvSpPr>
+          <p:cNvPr id="6" name="TextBox 5"/>
           <p:cNvSpPr txBox="1"/>
           <p:nvPr/>
         </p:nvSpPr>
@@ -4166,7 +4239,7 @@
           <a:lstStyle/>
           <a:p>
             <a:pPr>
-              <a:defRPr sz="2400">
+              <a:defRPr sz="2300">
                 <a:solidFill>
                   <a:srgbClr val="F1F5F9"/>
                 </a:solidFill>
@@ -4174,7 +4247,7 @@
               </a:defRPr>
             </a:pPr>
             <a:r>
-              <a:t>❓ Sentido pedagógico</a:t>
+              <a:t>📌 Puntos que deben quedar claros</a:t>
             </a:r>
           </a:p>
         </p:txBody>
@@ -4187,8 +4260,8 @@
         </p:nvSpPr>
         <p:spPr>
           <a:xfrm>
-            <a:off x="731520" y="1828800"/>
-            <a:ext cx="10698480" cy="4297680"/>
+            <a:off x="658368" y="1298448"/>
+            <a:ext cx="10881360" cy="502920"/>
           </a:xfrm>
           <a:prstGeom prst="rect">
             <a:avLst/>
@@ -4202,26 +4275,46 @@
           <a:lstStyle/>
           <a:p>
             <a:pPr>
-              <a:spcAft>
-                <a:spcPts val="1000"/>
-              </a:spcAft>
-              <a:defRPr sz="2000">
-                <a:solidFill>
-                  <a:srgbClr val="F1F5F9"/>
+              <a:defRPr sz="1100">
+                <a:solidFill>
+                  <a:srgbClr val="94A3B8"/>
                 </a:solidFill>
                 <a:latin typeface="Segoe UI"/>
               </a:defRPr>
             </a:pPr>
             <a:r>
-              <a:t>Por qué importa: Permite decidir desde dónde conviene partir y qué apoyos necesita cada estudiante.</a:t>
-            </a:r>
-          </a:p>
+              <a:t>Contenido derivado del guion de diapositivas.</a:t>
+            </a:r>
+          </a:p>
+        </p:txBody>
+      </p:sp>
+      <p:sp>
+        <p:nvSpPr>
+          <p:cNvPr id="6" name="TextBox 5"/>
+          <p:cNvSpPr txBox="1"/>
+          <p:nvPr/>
+        </p:nvSpPr>
+        <p:spPr>
+          <a:xfrm>
+            <a:off x="731520" y="1828800"/>
+            <a:ext cx="10698480" cy="4297680"/>
+          </a:xfrm>
+          <a:prstGeom prst="rect">
+            <a:avLst/>
+          </a:prstGeom>
+          <a:noFill/>
+        </p:spPr>
+        <p:txBody>
+          <a:bodyPr wrap="square">
+            <a:spAutoFit/>
+          </a:bodyPr>
+          <a:lstStyle/>
           <a:p>
             <a:pPr>
               <a:spcAft>
                 <a:spcPts val="1000"/>
               </a:spcAft>
-              <a:defRPr sz="2000">
+              <a:defRPr sz="1800">
                 <a:solidFill>
                   <a:srgbClr val="F1F5F9"/>
                 </a:solidFill>
@@ -4229,7 +4322,7 @@
               </a:defRPr>
             </a:pPr>
             <a:r>
-              <a:t>Qué hace: resultado → lectura por área → acción de apoyo</a:t>
+              <a:t>Python básico</a:t>
             </a:r>
           </a:p>
           <a:p>
@@ -4237,7 +4330,7 @@
               <a:spcAft>
                 <a:spcPts val="1000"/>
               </a:spcAft>
-              <a:defRPr sz="2000">
+              <a:defRPr sz="1800">
                 <a:solidFill>
                   <a:srgbClr val="F1F5F9"/>
                 </a:solidFill>
@@ -4245,7 +4338,7 @@
               </a:defRPr>
             </a:pPr>
             <a:r>
-              <a:t>Para qué sirve: Sirve para priorizar repaso, nivelar expectativas y organizar el acompañamiento docente desde la primera semana.</a:t>
+              <a:t>Lectura de tablas</a:t>
             </a:r>
           </a:p>
           <a:p>
@@ -4253,7 +4346,7 @@
               <a:spcAft>
                 <a:spcPts val="1000"/>
               </a:spcAft>
-              <a:defRPr sz="2000">
+              <a:defRPr sz="1800">
                 <a:solidFill>
                   <a:srgbClr val="F1F5F9"/>
                 </a:solidFill>
@@ -4261,7 +4354,55 @@
               </a:defRPr>
             </a:pPr>
             <a:r>
-              <a:t>Nota docente: Usa el resultado para ajustar ritmo, apoyos y ejemplos de las primeras clases.</a:t>
+              <a:t>Gráficos</a:t>
+            </a:r>
+          </a:p>
+          <a:p>
+            <a:pPr>
+              <a:spcAft>
+                <a:spcPts val="1000"/>
+              </a:spcAft>
+              <a:defRPr sz="1800">
+                <a:solidFill>
+                  <a:srgbClr val="F1F5F9"/>
+                </a:solidFill>
+                <a:latin typeface="Segoe UI"/>
+              </a:defRPr>
+            </a:pPr>
+            <a:r>
+              <a:t>Modelado inicial</a:t>
+            </a:r>
+          </a:p>
+          <a:p>
+            <a:pPr>
+              <a:spcAft>
+                <a:spcPts val="1000"/>
+              </a:spcAft>
+              <a:defRPr sz="1800">
+                <a:solidFill>
+                  <a:srgbClr val="F1F5F9"/>
+                </a:solidFill>
+                <a:latin typeface="Segoe UI"/>
+              </a:defRPr>
+            </a:pPr>
+            <a:r>
+              <a:t>Hábitos de trabajo</a:t>
+            </a:r>
+          </a:p>
+          <a:p>
+            <a:pPr>
+              <a:spcAft>
+                <a:spcPts val="1000"/>
+              </a:spcAft>
+              <a:defRPr sz="1800">
+                <a:solidFill>
+                  <a:srgbClr val="F1F5F9"/>
+                </a:solidFill>
+                <a:latin typeface="Segoe UI"/>
+              </a:defRPr>
+            </a:pPr>
+            <a:r>
+              <a:t>Cierre esperado: La siguiente parada es la clase 01: Fundamentos de Python aplicados a datos.</a:t>
             </a:r>
           </a:p>
         </p:txBody>
@@ -4405,7 +4546,7 @@
           <a:lstStyle/>
           <a:p>
             <a:pPr>
-              <a:defRPr sz="2400">
+              <a:defRPr sz="2300">
                 <a:solidFill>
                   <a:srgbClr val="F1F5F9"/>
                 </a:solidFill>
@@ -4413,7 +4554,7 @@
               </a:defRPr>
             </a:pPr>
             <a:r>
-              <a:t>🧩 Lectura del resultado diagnóstico</a:t>
+              <a:t>🧠 Base conceptual del módulo</a:t>
             </a:r>
           </a:p>
         </p:txBody>
@@ -4421,6 +4562,42 @@
       <p:sp>
         <p:nvSpPr>
           <p:cNvPr id="5" name="TextBox 4"/>
+          <p:cNvSpPr txBox="1"/>
+          <p:nvPr/>
+        </p:nvSpPr>
+        <p:spPr>
+          <a:xfrm>
+            <a:off x="658368" y="1298448"/>
+            <a:ext cx="10881360" cy="502920"/>
+          </a:xfrm>
+          <a:prstGeom prst="rect">
+            <a:avLst/>
+          </a:prstGeom>
+          <a:noFill/>
+        </p:spPr>
+        <p:txBody>
+          <a:bodyPr wrap="square">
+            <a:spAutoFit/>
+          </a:bodyPr>
+          <a:lstStyle/>
+          <a:p>
+            <a:pPr>
+              <a:defRPr sz="1100">
+                <a:solidFill>
+                  <a:srgbClr val="94A3B8"/>
+                </a:solidFill>
+                <a:latin typeface="Segoe UI"/>
+              </a:defRPr>
+            </a:pPr>
+            <a:r>
+              <a:t>Síntesis tomada desde teoria.md.</a:t>
+            </a:r>
+          </a:p>
+        </p:txBody>
+      </p:sp>
+      <p:sp>
+        <p:nvSpPr>
+          <p:cNvPr id="6" name="TextBox 5"/>
           <p:cNvSpPr txBox="1"/>
           <p:nvPr/>
         </p:nvSpPr>
@@ -4452,7 +4629,7 @@
               </a:defRPr>
             </a:pPr>
             <a:r>
-              <a:t>La meta no es etiquetar al estudiante, sino traducir el resultado en una ruta de trabajo concreta.</a:t>
+              <a:t>Diagnóstico breve, retroalimentación inmediata y acuerdo sobre la ruta de aprendizaje.</a:t>
             </a:r>
           </a:p>
           <a:p>
@@ -4468,7 +4645,7 @@
               </a:defRPr>
             </a:pPr>
             <a:r>
-              <a:t>Qué hace: resultado → lectura por área → acción de apoyo</a:t>
+              <a:t>Permite decidir desde dónde conviene partir y qué apoyos necesita cada estudiante.</a:t>
             </a:r>
           </a:p>
           <a:p>
@@ -4484,7 +4661,7 @@
               </a:defRPr>
             </a:pPr>
             <a:r>
-              <a:t>Para qué sirve: Sirve para priorizar repaso, nivelar expectativas y organizar el acompañamiento docente desde la primera semana.</a:t>
+              <a:t>La siguiente parada es la clase 01: Fundamentos de Python aplicados a datos.</a:t>
             </a:r>
           </a:p>
         </p:txBody>
@@ -4628,7 +4805,7 @@
           <a:lstStyle/>
           <a:p>
             <a:pPr>
-              <a:defRPr sz="2400">
+              <a:defRPr sz="2300">
                 <a:solidFill>
                   <a:srgbClr val="F1F5F9"/>
                 </a:solidFill>
@@ -4636,7 +4813,7 @@
               </a:defRPr>
             </a:pPr>
             <a:r>
-              <a:t>🧪 Práctica y cierre</a:t>
+              <a:t>⚠️ Errores frecuentes</a:t>
             </a:r>
           </a:p>
         </p:txBody>
@@ -4675,7 +4852,7 @@
               </a:defRPr>
             </a:pPr>
             <a:r>
-              <a:t>Pedir explicación de la pregunta antes de ejecutar.</a:t>
+              <a:t>Saltar al código sin aclarar la pregunta.</a:t>
             </a:r>
           </a:p>
           <a:p>
@@ -4691,7 +4868,7 @@
               </a:defRPr>
             </a:pPr>
             <a:r>
-              <a:t>Leer la salida y justificar cada decisión importante.</a:t>
+              <a:t>Ejecutar bloques sin leer la salida.</a:t>
             </a:r>
           </a:p>
           <a:p>
@@ -4707,23 +4884,7 @@
               </a:defRPr>
             </a:pPr>
             <a:r>
-              <a:t>Cerrar con una variación pequeña o conclusión breve.</a:t>
-            </a:r>
-          </a:p>
-          <a:p>
-            <a:pPr>
-              <a:spcAft>
-                <a:spcPts val="1000"/>
-              </a:spcAft>
-              <a:defRPr sz="2000">
-                <a:solidFill>
-                  <a:srgbClr val="F1F5F9"/>
-                </a:solidFill>
-                <a:latin typeface="Segoe UI"/>
-              </a:defRPr>
-            </a:pPr>
-            <a:r>
-              <a:t>La siguiente parada es la clase 01: Fundamentos de Python aplicados a datos.</a:t>
+              <a:t>Dejar bloques importantes sin comentarios o sin explicación oral.</a:t>
             </a:r>
           </a:p>
         </p:txBody>
@@ -4867,7 +5028,7 @@
           <a:lstStyle/>
           <a:p>
             <a:pPr>
-              <a:defRPr sz="2400">
+              <a:defRPr sz="2300">
                 <a:solidFill>
                   <a:srgbClr val="F1F5F9"/>
                 </a:solidFill>
@@ -4875,7 +5036,7 @@
               </a:defRPr>
             </a:pPr>
             <a:r>
-              <a:t>📚 Materiales del módulo</a:t>
+              <a:t>🧪 Práctica guiada</a:t>
             </a:r>
           </a:p>
         </p:txBody>
@@ -4888,8 +5049,8 @@
         </p:nvSpPr>
         <p:spPr>
           <a:xfrm>
-            <a:off x="658368" y="1325880"/>
-            <a:ext cx="10881360" cy="457200"/>
+            <a:off x="658368" y="1298448"/>
+            <a:ext cx="10881360" cy="502920"/>
           </a:xfrm>
           <a:prstGeom prst="rect">
             <a:avLst/>
@@ -4911,21 +5072,66 @@
               </a:defRPr>
             </a:pPr>
             <a:r>
-              <a:t>Archivos que conviene mostrar o entregar al grupo.</a:t>
-            </a:r>
-          </a:p>
-        </p:txBody>
-      </p:sp>
-      <p:sp>
-        <p:nvSpPr>
-          <p:cNvPr id="6" name="TextBox 5"/>
+              <a:t>Derivado del archivo ejercicios.md.</a:t>
+            </a:r>
+          </a:p>
+        </p:txBody>
+      </p:sp>
+      <p:sp>
+        <p:nvSpPr>
+          <p:cNvPr id="6" name="Rounded Rectangle 5"/>
+          <p:cNvSpPr/>
+          <p:nvPr/>
+        </p:nvSpPr>
+        <p:spPr>
+          <a:xfrm>
+            <a:off x="731520" y="1783080"/>
+            <a:ext cx="4663440" cy="4114800"/>
+          </a:xfrm>
+          <a:prstGeom prst="roundRect">
+            <a:avLst/>
+          </a:prstGeom>
+          <a:solidFill>
+            <a:srgbClr val="111827"/>
+          </a:solidFill>
+          <a:ln>
+            <a:solidFill>
+              <a:srgbClr val="111827"/>
+            </a:solidFill>
+          </a:ln>
+        </p:spPr>
+        <p:style>
+          <a:lnRef idx="1">
+            <a:schemeClr val="accent1"/>
+          </a:lnRef>
+          <a:fillRef idx="3">
+            <a:schemeClr val="accent1"/>
+          </a:fillRef>
+          <a:effectRef idx="2">
+            <a:schemeClr val="accent1"/>
+          </a:effectRef>
+          <a:fontRef idx="minor">
+            <a:schemeClr val="lt1"/>
+          </a:fontRef>
+        </p:style>
+        <p:txBody>
+          <a:bodyPr rtlCol="0" anchor="ctr"/>
+          <a:lstStyle/>
+          <a:p>
+            <a:pPr algn="ctr"/>
+          </a:p>
+        </p:txBody>
+      </p:sp>
+      <p:sp>
+        <p:nvSpPr>
+          <p:cNvPr id="7" name="TextBox 6"/>
           <p:cNvSpPr txBox="1"/>
           <p:nvPr/>
         </p:nvSpPr>
         <p:spPr>
           <a:xfrm>
-            <a:off x="731520" y="1828800"/>
-            <a:ext cx="10698480" cy="4297680"/>
+            <a:off x="914400" y="1965960"/>
+            <a:ext cx="4297680" cy="365760"/>
           </a:xfrm>
           <a:prstGeom prst="rect">
             <a:avLst/>
@@ -4933,6 +5139,42 @@
           <a:noFill/>
         </p:spPr>
         <p:txBody>
+          <a:bodyPr wrap="none">
+            <a:spAutoFit/>
+          </a:bodyPr>
+          <a:lstStyle/>
+          <a:p>
+            <a:pPr>
+              <a:defRPr sz="1600">
+                <a:solidFill>
+                  <a:srgbClr val="22C55E"/>
+                </a:solidFill>
+                <a:latin typeface="Segoe UI Semibold"/>
+              </a:defRPr>
+            </a:pPr>
+            <a:r>
+              <a:t>Trabajo guiado</a:t>
+            </a:r>
+          </a:p>
+        </p:txBody>
+      </p:sp>
+      <p:sp>
+        <p:nvSpPr>
+          <p:cNvPr id="8" name="TextBox 7"/>
+          <p:cNvSpPr txBox="1"/>
+          <p:nvPr/>
+        </p:nvSpPr>
+        <p:spPr>
+          <a:xfrm>
+            <a:off x="914400" y="2377440"/>
+            <a:ext cx="4297680" cy="3200400"/>
+          </a:xfrm>
+          <a:prstGeom prst="rect">
+            <a:avLst/>
+          </a:prstGeom>
+          <a:noFill/>
+        </p:spPr>
+        <p:txBody>
           <a:bodyPr wrap="square">
             <a:spAutoFit/>
           </a:bodyPr>
@@ -4940,9 +5182,9 @@
           <a:p>
             <a:pPr>
               <a:spcAft>
-                <a:spcPts val="1000"/>
+                <a:spcPts val="800"/>
               </a:spcAft>
-              <a:defRPr sz="1800">
+              <a:defRPr sz="1700">
                 <a:solidFill>
                   <a:srgbClr val="F1F5F9"/>
                 </a:solidFill>
@@ -4950,15 +5192,15 @@
               </a:defRPr>
             </a:pPr>
             <a:r>
-              <a:t>Disponible: README.md</a:t>
+              <a:t>Resume con tus palabras la pregunta principal del módulo.</a:t>
             </a:r>
           </a:p>
           <a:p>
             <a:pPr>
               <a:spcAft>
-                <a:spcPts val="1000"/>
+                <a:spcPts val="800"/>
               </a:spcAft>
-              <a:defRPr sz="1800">
+              <a:defRPr sz="1700">
                 <a:solidFill>
                   <a:srgbClr val="F1F5F9"/>
                 </a:solidFill>
@@ -4966,15 +5208,15 @@
               </a:defRPr>
             </a:pPr>
             <a:r>
-              <a:t>Disponible: slides.md</a:t>
+              <a:t>Ejecuta o revisa el bloque principal y explica la salida.</a:t>
             </a:r>
           </a:p>
           <a:p>
             <a:pPr>
               <a:spcAft>
-                <a:spcPts val="1000"/>
+                <a:spcPts val="800"/>
               </a:spcAft>
-              <a:defRPr sz="1800">
+              <a:defRPr sz="1700">
                 <a:solidFill>
                   <a:srgbClr val="F1F5F9"/>
                 </a:solidFill>
@@ -4982,15 +5224,119 @@
               </a:defRPr>
             </a:pPr>
             <a:r>
-              <a:t>Disponible: teoria.md</a:t>
-            </a:r>
-          </a:p>
+              <a:t>Realiza una variación pequeña y anota qué cambió y por qué.</a:t>
+            </a:r>
+          </a:p>
+        </p:txBody>
+      </p:sp>
+      <p:sp>
+        <p:nvSpPr>
+          <p:cNvPr id="9" name="Rounded Rectangle 8"/>
+          <p:cNvSpPr/>
+          <p:nvPr/>
+        </p:nvSpPr>
+        <p:spPr>
+          <a:xfrm>
+            <a:off x="6217920" y="1783080"/>
+            <a:ext cx="4663440" cy="4114800"/>
+          </a:xfrm>
+          <a:prstGeom prst="roundRect">
+            <a:avLst/>
+          </a:prstGeom>
+          <a:solidFill>
+            <a:srgbClr val="111827"/>
+          </a:solidFill>
+          <a:ln>
+            <a:solidFill>
+              <a:srgbClr val="111827"/>
+            </a:solidFill>
+          </a:ln>
+        </p:spPr>
+        <p:style>
+          <a:lnRef idx="1">
+            <a:schemeClr val="accent1"/>
+          </a:lnRef>
+          <a:fillRef idx="3">
+            <a:schemeClr val="accent1"/>
+          </a:fillRef>
+          <a:effectRef idx="2">
+            <a:schemeClr val="accent1"/>
+          </a:effectRef>
+          <a:fontRef idx="minor">
+            <a:schemeClr val="lt1"/>
+          </a:fontRef>
+        </p:style>
+        <p:txBody>
+          <a:bodyPr rtlCol="0" anchor="ctr"/>
+          <a:lstStyle/>
+          <a:p>
+            <a:pPr algn="ctr"/>
+          </a:p>
+        </p:txBody>
+      </p:sp>
+      <p:sp>
+        <p:nvSpPr>
+          <p:cNvPr id="10" name="TextBox 9"/>
+          <p:cNvSpPr txBox="1"/>
+          <p:nvPr/>
+        </p:nvSpPr>
+        <p:spPr>
+          <a:xfrm>
+            <a:off x="6400800" y="1965960"/>
+            <a:ext cx="4297680" cy="365760"/>
+          </a:xfrm>
+          <a:prstGeom prst="rect">
+            <a:avLst/>
+          </a:prstGeom>
+          <a:noFill/>
+        </p:spPr>
+        <p:txBody>
+          <a:bodyPr wrap="none">
+            <a:spAutoFit/>
+          </a:bodyPr>
+          <a:lstStyle/>
+          <a:p>
+            <a:pPr>
+              <a:defRPr sz="1600">
+                <a:solidFill>
+                  <a:srgbClr val="22C55E"/>
+                </a:solidFill>
+                <a:latin typeface="Segoe UI Semibold"/>
+              </a:defRPr>
+            </a:pPr>
+            <a:r>
+              <a:t>Autocorrección</a:t>
+            </a:r>
+          </a:p>
+        </p:txBody>
+      </p:sp>
+      <p:sp>
+        <p:nvSpPr>
+          <p:cNvPr id="11" name="TextBox 10"/>
+          <p:cNvSpPr txBox="1"/>
+          <p:nvPr/>
+        </p:nvSpPr>
+        <p:spPr>
+          <a:xfrm>
+            <a:off x="6400800" y="2377440"/>
+            <a:ext cx="4297680" cy="3200400"/>
+          </a:xfrm>
+          <a:prstGeom prst="rect">
+            <a:avLst/>
+          </a:prstGeom>
+          <a:noFill/>
+        </p:spPr>
+        <p:txBody>
+          <a:bodyPr wrap="square">
+            <a:spAutoFit/>
+          </a:bodyPr>
+          <a:lstStyle/>
           <a:p>
             <a:pPr>
               <a:spcAft>
-                <a:spcPts val="1000"/>
+                <a:spcPts val="800"/>
               </a:spcAft>
-              <a:defRPr sz="1800">
+              <a:defRPr sz="1700">
                 <a:solidFill>
                   <a:srgbClr val="F1F5F9"/>
                 </a:solidFill>
@@ -4998,15 +5344,15 @@
               </a:defRPr>
             </a:pPr>
             <a:r>
-              <a:t>Disponible: ejercicios.md</a:t>
+              <a:t>El resultado responde a la pregunta planteada.</a:t>
             </a:r>
           </a:p>
           <a:p>
             <a:pPr>
               <a:spcAft>
-                <a:spcPts val="1000"/>
+                <a:spcPts val="800"/>
               </a:spcAft>
-              <a:defRPr sz="1800">
+              <a:defRPr sz="1700">
                 <a:solidFill>
                   <a:srgbClr val="F1F5F9"/>
                 </a:solidFill>
@@ -5014,15 +5360,15 @@
               </a:defRPr>
             </a:pPr>
             <a:r>
-              <a:t>Disponible: homework.md</a:t>
+              <a:t>El código está ordenado y comentado en los puntos clave.</a:t>
             </a:r>
           </a:p>
           <a:p>
             <a:pPr>
               <a:spcAft>
-                <a:spcPts val="1000"/>
+                <a:spcPts val="800"/>
               </a:spcAft>
-              <a:defRPr sz="1800">
+              <a:defRPr sz="1700">
                 <a:solidFill>
                   <a:srgbClr val="F1F5F9"/>
                 </a:solidFill>
@@ -5030,7 +5376,499 @@
               </a:defRPr>
             </a:pPr>
             <a:r>
-              <a:t>Disponible: quiz.json</a:t>
+              <a:t>La salida se puede explicar con lenguaje simple.</a:t>
+            </a:r>
+          </a:p>
+        </p:txBody>
+      </p:sp>
+    </p:spTree>
+  </p:cSld>
+  <p:clrMapOvr>
+    <a:masterClrMapping/>
+  </p:clrMapOvr>
+</p:sld>
+</file>
+
+<file path=ppt/slides/slide8.xml><?xml version="1.0" encoding="utf-8"?>
+<p:sld xmlns:a="http://schemas.openxmlformats.org/drawingml/2006/main" xmlns:p="http://schemas.openxmlformats.org/presentationml/2006/main" xmlns:r="http://schemas.openxmlformats.org/officeDocument/2006/relationships">
+  <p:cSld>
+    <p:bg>
+      <p:bgPr>
+        <a:solidFill>
+          <a:srgbClr val="0F172A"/>
+        </a:solidFill>
+        <a:effectLst/>
+      </p:bgPr>
+    </p:bg>
+    <p:spTree>
+      <p:nvGrpSpPr>
+        <p:cNvPr id="1" name=""/>
+        <p:cNvGrpSpPr/>
+        <p:nvPr/>
+      </p:nvGrpSpPr>
+      <p:grpSpPr/>
+      <p:sp>
+        <p:nvSpPr>
+          <p:cNvPr id="2" name="Rectangle 1"/>
+          <p:cNvSpPr/>
+          <p:nvPr/>
+        </p:nvSpPr>
+        <p:spPr>
+          <a:xfrm>
+            <a:off x="0" y="0"/>
+            <a:ext cx="12191695" cy="411480"/>
+          </a:xfrm>
+          <a:prstGeom prst="rect">
+            <a:avLst/>
+          </a:prstGeom>
+          <a:solidFill>
+            <a:srgbClr val="111827"/>
+          </a:solidFill>
+          <a:ln>
+            <a:solidFill>
+              <a:srgbClr val="111827"/>
+            </a:solidFill>
+          </a:ln>
+        </p:spPr>
+        <p:style>
+          <a:lnRef idx="1">
+            <a:schemeClr val="accent1"/>
+          </a:lnRef>
+          <a:fillRef idx="3">
+            <a:schemeClr val="accent1"/>
+          </a:fillRef>
+          <a:effectRef idx="2">
+            <a:schemeClr val="accent1"/>
+          </a:effectRef>
+          <a:fontRef idx="minor">
+            <a:schemeClr val="lt1"/>
+          </a:fontRef>
+        </p:style>
+        <p:txBody>
+          <a:bodyPr rtlCol="0" anchor="ctr"/>
+          <a:lstStyle/>
+          <a:p>
+            <a:pPr algn="ctr"/>
+          </a:p>
+        </p:txBody>
+      </p:sp>
+      <p:sp>
+        <p:nvSpPr>
+          <p:cNvPr id="3" name="Rectangle 2"/>
+          <p:cNvSpPr/>
+          <p:nvPr/>
+        </p:nvSpPr>
+        <p:spPr>
+          <a:xfrm>
+            <a:off x="0" y="411480"/>
+            <a:ext cx="12191695" cy="73152"/>
+          </a:xfrm>
+          <a:prstGeom prst="rect">
+            <a:avLst/>
+          </a:prstGeom>
+          <a:solidFill>
+            <a:srgbClr val="22C55E"/>
+          </a:solidFill>
+          <a:ln>
+            <a:solidFill>
+              <a:srgbClr val="22C55E"/>
+            </a:solidFill>
+          </a:ln>
+        </p:spPr>
+        <p:style>
+          <a:lnRef idx="1">
+            <a:schemeClr val="accent1"/>
+          </a:lnRef>
+          <a:fillRef idx="3">
+            <a:schemeClr val="accent1"/>
+          </a:fillRef>
+          <a:effectRef idx="2">
+            <a:schemeClr val="accent1"/>
+          </a:effectRef>
+          <a:fontRef idx="minor">
+            <a:schemeClr val="lt1"/>
+          </a:fontRef>
+        </p:style>
+        <p:txBody>
+          <a:bodyPr rtlCol="0" anchor="ctr"/>
+          <a:lstStyle/>
+          <a:p>
+            <a:pPr algn="ctr"/>
+          </a:p>
+        </p:txBody>
+      </p:sp>
+      <p:sp>
+        <p:nvSpPr>
+          <p:cNvPr id="4" name="TextBox 3"/>
+          <p:cNvSpPr txBox="1"/>
+          <p:nvPr/>
+        </p:nvSpPr>
+        <p:spPr>
+          <a:xfrm>
+            <a:off x="640080" y="731520"/>
+            <a:ext cx="10881360" cy="731520"/>
+          </a:xfrm>
+          <a:prstGeom prst="rect">
+            <a:avLst/>
+          </a:prstGeom>
+          <a:noFill/>
+        </p:spPr>
+        <p:txBody>
+          <a:bodyPr wrap="square" anchor="ctr">
+            <a:spAutoFit/>
+          </a:bodyPr>
+          <a:lstStyle/>
+          <a:p>
+            <a:pPr>
+              <a:defRPr sz="2300">
+                <a:solidFill>
+                  <a:srgbClr val="F1F5F9"/>
+                </a:solidFill>
+                <a:latin typeface="Segoe UI Semibold"/>
+              </a:defRPr>
+            </a:pPr>
+            <a:r>
+              <a:t>📝 Tarea y evidencia final</a:t>
+            </a:r>
+          </a:p>
+        </p:txBody>
+      </p:sp>
+      <p:sp>
+        <p:nvSpPr>
+          <p:cNvPr id="5" name="TextBox 4"/>
+          <p:cNvSpPr txBox="1"/>
+          <p:nvPr/>
+        </p:nvSpPr>
+        <p:spPr>
+          <a:xfrm>
+            <a:off x="658368" y="1298448"/>
+            <a:ext cx="10881360" cy="502920"/>
+          </a:xfrm>
+          <a:prstGeom prst="rect">
+            <a:avLst/>
+          </a:prstGeom>
+          <a:noFill/>
+        </p:spPr>
+        <p:txBody>
+          <a:bodyPr wrap="square">
+            <a:spAutoFit/>
+          </a:bodyPr>
+          <a:lstStyle/>
+          <a:p>
+            <a:pPr>
+              <a:defRPr sz="1100">
+                <a:solidFill>
+                  <a:srgbClr val="94A3B8"/>
+                </a:solidFill>
+                <a:latin typeface="Segoe UI"/>
+              </a:defRPr>
+            </a:pPr>
+            <a:r>
+              <a:t>Construido desde homework.md y archivos complementarios.</a:t>
+            </a:r>
+          </a:p>
+        </p:txBody>
+      </p:sp>
+      <p:sp>
+        <p:nvSpPr>
+          <p:cNvPr id="6" name="Rounded Rectangle 5"/>
+          <p:cNvSpPr/>
+          <p:nvPr/>
+        </p:nvSpPr>
+        <p:spPr>
+          <a:xfrm>
+            <a:off x="731520" y="1783080"/>
+            <a:ext cx="4663440" cy="4114800"/>
+          </a:xfrm>
+          <a:prstGeom prst="roundRect">
+            <a:avLst/>
+          </a:prstGeom>
+          <a:solidFill>
+            <a:srgbClr val="111827"/>
+          </a:solidFill>
+          <a:ln>
+            <a:solidFill>
+              <a:srgbClr val="111827"/>
+            </a:solidFill>
+          </a:ln>
+        </p:spPr>
+        <p:style>
+          <a:lnRef idx="1">
+            <a:schemeClr val="accent1"/>
+          </a:lnRef>
+          <a:fillRef idx="3">
+            <a:schemeClr val="accent1"/>
+          </a:fillRef>
+          <a:effectRef idx="2">
+            <a:schemeClr val="accent1"/>
+          </a:effectRef>
+          <a:fontRef idx="minor">
+            <a:schemeClr val="lt1"/>
+          </a:fontRef>
+        </p:style>
+        <p:txBody>
+          <a:bodyPr rtlCol="0" anchor="ctr"/>
+          <a:lstStyle/>
+          <a:p>
+            <a:pPr algn="ctr"/>
+          </a:p>
+        </p:txBody>
+      </p:sp>
+      <p:sp>
+        <p:nvSpPr>
+          <p:cNvPr id="7" name="TextBox 6"/>
+          <p:cNvSpPr txBox="1"/>
+          <p:nvPr/>
+        </p:nvSpPr>
+        <p:spPr>
+          <a:xfrm>
+            <a:off x="914400" y="1965960"/>
+            <a:ext cx="4297680" cy="365760"/>
+          </a:xfrm>
+          <a:prstGeom prst="rect">
+            <a:avLst/>
+          </a:prstGeom>
+          <a:noFill/>
+        </p:spPr>
+        <p:txBody>
+          <a:bodyPr wrap="none">
+            <a:spAutoFit/>
+          </a:bodyPr>
+          <a:lstStyle/>
+          <a:p>
+            <a:pPr>
+              <a:defRPr sz="1600">
+                <a:solidFill>
+                  <a:srgbClr val="22C55E"/>
+                </a:solidFill>
+                <a:latin typeface="Segoe UI Semibold"/>
+              </a:defRPr>
+            </a:pPr>
+            <a:r>
+              <a:t>Entregables</a:t>
+            </a:r>
+          </a:p>
+        </p:txBody>
+      </p:sp>
+      <p:sp>
+        <p:nvSpPr>
+          <p:cNvPr id="8" name="TextBox 7"/>
+          <p:cNvSpPr txBox="1"/>
+          <p:nvPr/>
+        </p:nvSpPr>
+        <p:spPr>
+          <a:xfrm>
+            <a:off x="914400" y="2377440"/>
+            <a:ext cx="4297680" cy="3200400"/>
+          </a:xfrm>
+          <a:prstGeom prst="rect">
+            <a:avLst/>
+          </a:prstGeom>
+          <a:noFill/>
+        </p:spPr>
+        <p:txBody>
+          <a:bodyPr wrap="square">
+            <a:spAutoFit/>
+          </a:bodyPr>
+          <a:lstStyle/>
+          <a:p>
+            <a:pPr>
+              <a:spcAft>
+                <a:spcPts val="800"/>
+              </a:spcAft>
+              <a:defRPr sz="1700">
+                <a:solidFill>
+                  <a:srgbClr val="F1F5F9"/>
+                </a:solidFill>
+                <a:latin typeface="Segoe UI"/>
+              </a:defRPr>
+            </a:pPr>
+            <a:r>
+              <a:t>Reflexión breve sobre fortalezas y vacíos.</a:t>
+            </a:r>
+          </a:p>
+          <a:p>
+            <a:pPr>
+              <a:spcAft>
+                <a:spcPts val="800"/>
+              </a:spcAft>
+              <a:defRPr sz="1700">
+                <a:solidFill>
+                  <a:srgbClr val="F1F5F9"/>
+                </a:solidFill>
+                <a:latin typeface="Segoe UI"/>
+              </a:defRPr>
+            </a:pPr>
+            <a:r>
+              <a:t>Compromiso de trabajo para la clase siguiente.</a:t>
+            </a:r>
+          </a:p>
+          <a:p>
+            <a:pPr>
+              <a:spcAft>
+                <a:spcPts val="800"/>
+              </a:spcAft>
+              <a:defRPr sz="1700">
+                <a:solidFill>
+                  <a:srgbClr val="F1F5F9"/>
+                </a:solidFill>
+                <a:latin typeface="Segoe UI"/>
+              </a:defRPr>
+            </a:pPr>
+            <a:r>
+              <a:t>Dudas iniciales que quieras resolver con el docente.</a:t>
+            </a:r>
+          </a:p>
+        </p:txBody>
+      </p:sp>
+      <p:sp>
+        <p:nvSpPr>
+          <p:cNvPr id="9" name="Rounded Rectangle 8"/>
+          <p:cNvSpPr/>
+          <p:nvPr/>
+        </p:nvSpPr>
+        <p:spPr>
+          <a:xfrm>
+            <a:off x="6217920" y="1783080"/>
+            <a:ext cx="4663440" cy="4114800"/>
+          </a:xfrm>
+          <a:prstGeom prst="roundRect">
+            <a:avLst/>
+          </a:prstGeom>
+          <a:solidFill>
+            <a:srgbClr val="111827"/>
+          </a:solidFill>
+          <a:ln>
+            <a:solidFill>
+              <a:srgbClr val="111827"/>
+            </a:solidFill>
+          </a:ln>
+        </p:spPr>
+        <p:style>
+          <a:lnRef idx="1">
+            <a:schemeClr val="accent1"/>
+          </a:lnRef>
+          <a:fillRef idx="3">
+            <a:schemeClr val="accent1"/>
+          </a:fillRef>
+          <a:effectRef idx="2">
+            <a:schemeClr val="accent1"/>
+          </a:effectRef>
+          <a:fontRef idx="minor">
+            <a:schemeClr val="lt1"/>
+          </a:fontRef>
+        </p:style>
+        <p:txBody>
+          <a:bodyPr rtlCol="0" anchor="ctr"/>
+          <a:lstStyle/>
+          <a:p>
+            <a:pPr algn="ctr"/>
+          </a:p>
+        </p:txBody>
+      </p:sp>
+      <p:sp>
+        <p:nvSpPr>
+          <p:cNvPr id="10" name="TextBox 9"/>
+          <p:cNvSpPr txBox="1"/>
+          <p:nvPr/>
+        </p:nvSpPr>
+        <p:spPr>
+          <a:xfrm>
+            <a:off x="6400800" y="1965960"/>
+            <a:ext cx="4297680" cy="365760"/>
+          </a:xfrm>
+          <a:prstGeom prst="rect">
+            <a:avLst/>
+          </a:prstGeom>
+          <a:noFill/>
+        </p:spPr>
+        <p:txBody>
+          <a:bodyPr wrap="none">
+            <a:spAutoFit/>
+          </a:bodyPr>
+          <a:lstStyle/>
+          <a:p>
+            <a:pPr>
+              <a:defRPr sz="1600">
+                <a:solidFill>
+                  <a:srgbClr val="22C55E"/>
+                </a:solidFill>
+                <a:latin typeface="Segoe UI Semibold"/>
+              </a:defRPr>
+            </a:pPr>
+            <a:r>
+              <a:t>Autoevaluación o apoyo</a:t>
+            </a:r>
+          </a:p>
+        </p:txBody>
+      </p:sp>
+      <p:sp>
+        <p:nvSpPr>
+          <p:cNvPr id="11" name="TextBox 10"/>
+          <p:cNvSpPr txBox="1"/>
+          <p:nvPr/>
+        </p:nvSpPr>
+        <p:spPr>
+          <a:xfrm>
+            <a:off x="6400800" y="2377440"/>
+            <a:ext cx="4297680" cy="3200400"/>
+          </a:xfrm>
+          <a:prstGeom prst="rect">
+            <a:avLst/>
+          </a:prstGeom>
+          <a:noFill/>
+        </p:spPr>
+        <p:txBody>
+          <a:bodyPr wrap="square">
+            <a:spAutoFit/>
+          </a:bodyPr>
+          <a:lstStyle/>
+          <a:p>
+            <a:pPr>
+              <a:spcAft>
+                <a:spcPts val="800"/>
+              </a:spcAft>
+              <a:defRPr sz="1700">
+                <a:solidFill>
+                  <a:srgbClr val="F1F5F9"/>
+                </a:solidFill>
+                <a:latin typeface="Segoe UI"/>
+              </a:defRPr>
+            </a:pPr>
+            <a:r>
+              <a:t>Entendí la lógica general del diagnóstico.</a:t>
+            </a:r>
+          </a:p>
+          <a:p>
+            <a:pPr>
+              <a:spcAft>
+                <a:spcPts val="800"/>
+              </a:spcAft>
+              <a:defRPr sz="1700">
+                <a:solidFill>
+                  <a:srgbClr val="F1F5F9"/>
+                </a:solidFill>
+                <a:latin typeface="Segoe UI"/>
+              </a:defRPr>
+            </a:pPr>
+            <a:r>
+              <a:t>Puedo identificar en qué áreas necesito refuerzo.</a:t>
+            </a:r>
+          </a:p>
+          <a:p>
+            <a:pPr>
+              <a:spcAft>
+                <a:spcPts val="800"/>
+              </a:spcAft>
+              <a:defRPr sz="1700">
+                <a:solidFill>
+                  <a:srgbClr val="F1F5F9"/>
+                </a:solidFill>
+                <a:latin typeface="Segoe UI"/>
+              </a:defRPr>
+            </a:pPr>
+            <a:r>
+              <a:t>Sé cuál será mi foco de mejora en la clase siguiente.</a:t>
             </a:r>
           </a:p>
         </p:txBody>

</xml_diff>